<commit_message>
Did  the cone and sphere docs
introduce the {Model}, {Relationship}, {Thought Experiment} stereotypes.
used them to do the cone and Sphere models
</commit_message>
<xml_diff>
--- a/docs/figures/new diagrams 4.pptx
+++ b/docs/figures/new diagrams 4.pptx
@@ -7,6 +7,7 @@
   <p:sldIdLst>
     <p:sldId id="288" r:id="rId2"/>
     <p:sldId id="289" r:id="rId3"/>
+    <p:sldId id="290" r:id="rId4"/>
   </p:sldIdLst>
   <p:sldSz cx="12192000" cy="6858000"/>
   <p:notesSz cx="6858000" cy="9144000"/>
@@ -115,13 +116,14 @@
           <p14:sldIdLst>
             <p14:sldId id="288"/>
             <p14:sldId id="289"/>
+            <p14:sldId id="290"/>
           </p14:sldIdLst>
         </p14:section>
       </p14:sectionLst>
     </p:ext>
     <p:ext uri="{EFAFB233-063F-42B5-8137-9DF3F51BA10A}">
       <p15:sldGuideLst xmlns:p15="http://schemas.microsoft.com/office/powerpoint/2012/main">
-        <p15:guide id="1" orient="horz" pos="2160" userDrawn="1">
+        <p15:guide id="1" orient="horz" pos="2137" userDrawn="1">
           <p15:clr>
             <a:srgbClr val="A4A3A4"/>
           </p15:clr>
@@ -286,7 +288,7 @@
           <a:p>
             <a:fld id="{783195BA-A24A-42A8-94D4-15E9273B559F}" type="datetimeFigureOut">
               <a:rPr lang="en-AU" smtClean="0"/>
-              <a:t>16/06/2026</a:t>
+              <a:t>17/06/2026</a:t>
             </a:fld>
             <a:endParaRPr lang="en-AU"/>
           </a:p>
@@ -486,7 +488,7 @@
           <a:p>
             <a:fld id="{783195BA-A24A-42A8-94D4-15E9273B559F}" type="datetimeFigureOut">
               <a:rPr lang="en-AU" smtClean="0"/>
-              <a:t>16/06/2026</a:t>
+              <a:t>17/06/2026</a:t>
             </a:fld>
             <a:endParaRPr lang="en-AU"/>
           </a:p>
@@ -696,7 +698,7 @@
           <a:p>
             <a:fld id="{783195BA-A24A-42A8-94D4-15E9273B559F}" type="datetimeFigureOut">
               <a:rPr lang="en-AU" smtClean="0"/>
-              <a:t>16/06/2026</a:t>
+              <a:t>17/06/2026</a:t>
             </a:fld>
             <a:endParaRPr lang="en-AU"/>
           </a:p>
@@ -896,7 +898,7 @@
           <a:p>
             <a:fld id="{783195BA-A24A-42A8-94D4-15E9273B559F}" type="datetimeFigureOut">
               <a:rPr lang="en-AU" smtClean="0"/>
-              <a:t>16/06/2026</a:t>
+              <a:t>17/06/2026</a:t>
             </a:fld>
             <a:endParaRPr lang="en-AU"/>
           </a:p>
@@ -1172,7 +1174,7 @@
           <a:p>
             <a:fld id="{783195BA-A24A-42A8-94D4-15E9273B559F}" type="datetimeFigureOut">
               <a:rPr lang="en-AU" smtClean="0"/>
-              <a:t>16/06/2026</a:t>
+              <a:t>17/06/2026</a:t>
             </a:fld>
             <a:endParaRPr lang="en-AU"/>
           </a:p>
@@ -1440,7 +1442,7 @@
           <a:p>
             <a:fld id="{783195BA-A24A-42A8-94D4-15E9273B559F}" type="datetimeFigureOut">
               <a:rPr lang="en-AU" smtClean="0"/>
-              <a:t>16/06/2026</a:t>
+              <a:t>17/06/2026</a:t>
             </a:fld>
             <a:endParaRPr lang="en-AU"/>
           </a:p>
@@ -1855,7 +1857,7 @@
           <a:p>
             <a:fld id="{783195BA-A24A-42A8-94D4-15E9273B559F}" type="datetimeFigureOut">
               <a:rPr lang="en-AU" smtClean="0"/>
-              <a:t>16/06/2026</a:t>
+              <a:t>17/06/2026</a:t>
             </a:fld>
             <a:endParaRPr lang="en-AU"/>
           </a:p>
@@ -1997,7 +1999,7 @@
           <a:p>
             <a:fld id="{783195BA-A24A-42A8-94D4-15E9273B559F}" type="datetimeFigureOut">
               <a:rPr lang="en-AU" smtClean="0"/>
-              <a:t>16/06/2026</a:t>
+              <a:t>17/06/2026</a:t>
             </a:fld>
             <a:endParaRPr lang="en-AU"/>
           </a:p>
@@ -2110,7 +2112,7 @@
           <a:p>
             <a:fld id="{783195BA-A24A-42A8-94D4-15E9273B559F}" type="datetimeFigureOut">
               <a:rPr lang="en-AU" smtClean="0"/>
-              <a:t>16/06/2026</a:t>
+              <a:t>17/06/2026</a:t>
             </a:fld>
             <a:endParaRPr lang="en-AU"/>
           </a:p>
@@ -2423,7 +2425,7 @@
           <a:p>
             <a:fld id="{783195BA-A24A-42A8-94D4-15E9273B559F}" type="datetimeFigureOut">
               <a:rPr lang="en-AU" smtClean="0"/>
-              <a:t>16/06/2026</a:t>
+              <a:t>17/06/2026</a:t>
             </a:fld>
             <a:endParaRPr lang="en-AU"/>
           </a:p>
@@ -2712,7 +2714,7 @@
           <a:p>
             <a:fld id="{783195BA-A24A-42A8-94D4-15E9273B559F}" type="datetimeFigureOut">
               <a:rPr lang="en-AU" smtClean="0"/>
-              <a:t>16/06/2026</a:t>
+              <a:t>17/06/2026</a:t>
             </a:fld>
             <a:endParaRPr lang="en-AU"/>
           </a:p>
@@ -2955,7 +2957,7 @@
           <a:p>
             <a:fld id="{783195BA-A24A-42A8-94D4-15E9273B559F}" type="datetimeFigureOut">
               <a:rPr lang="en-AU" smtClean="0"/>
-              <a:t>16/06/2026</a:t>
+              <a:t>17/06/2026</a:t>
             </a:fld>
             <a:endParaRPr lang="en-AU"/>
           </a:p>
@@ -6560,6 +6562,1672 @@
 </p:sld>
 </file>
 
+<file path=ppt/slides/slide3.xml><?xml version="1.0" encoding="utf-8"?>
+<p:sld xmlns:a="http://schemas.openxmlformats.org/drawingml/2006/main" xmlns:r="http://schemas.openxmlformats.org/officeDocument/2006/relationships" xmlns:p="http://schemas.openxmlformats.org/presentationml/2006/main">
+  <p:cSld>
+    <p:bg>
+      <p:bgPr>
+        <a:solidFill>
+          <a:schemeClr val="bg1"/>
+        </a:solidFill>
+        <a:effectLst/>
+      </p:bgPr>
+    </p:bg>
+    <p:spTree>
+      <p:nvGrpSpPr>
+        <p:cNvPr id="1" name=""/>
+        <p:cNvGrpSpPr/>
+        <p:nvPr/>
+      </p:nvGrpSpPr>
+      <p:grpSpPr>
+        <a:xfrm>
+          <a:off x="0" y="0"/>
+          <a:ext cx="0" cy="0"/>
+          <a:chOff x="0" y="0"/>
+          <a:chExt cx="0" cy="0"/>
+        </a:xfrm>
+      </p:grpSpPr>
+      <p:sp>
+        <p:nvSpPr>
+          <p:cNvPr id="3" name="Oval 2">
+            <a:extLst>
+              <a:ext uri="{FF2B5EF4-FFF2-40B4-BE49-F238E27FC236}">
+                <a16:creationId xmlns:a16="http://schemas.microsoft.com/office/drawing/2014/main" id="{1EC0042E-9560-4C3A-886D-31CF423EBC97}"/>
+              </a:ext>
+            </a:extLst>
+          </p:cNvPr>
+          <p:cNvSpPr/>
+          <p:nvPr/>
+        </p:nvSpPr>
+        <p:spPr>
+          <a:xfrm>
+            <a:off x="2097451" y="4488232"/>
+            <a:ext cx="5760000" cy="672634"/>
+          </a:xfrm>
+          <a:prstGeom prst="ellipse">
+            <a:avLst/>
+          </a:prstGeom>
+          <a:noFill/>
+          <a:ln w="38100">
+            <a:solidFill>
+              <a:srgbClr val="002060"/>
+            </a:solidFill>
+          </a:ln>
+        </p:spPr>
+        <p:style>
+          <a:lnRef idx="2">
+            <a:schemeClr val="accent1">
+              <a:shade val="50000"/>
+            </a:schemeClr>
+          </a:lnRef>
+          <a:fillRef idx="1">
+            <a:schemeClr val="accent1"/>
+          </a:fillRef>
+          <a:effectRef idx="0">
+            <a:schemeClr val="accent1"/>
+          </a:effectRef>
+          <a:fontRef idx="minor">
+            <a:schemeClr val="lt1"/>
+          </a:fontRef>
+        </p:style>
+        <p:txBody>
+          <a:bodyPr rtlCol="0" anchor="ctr"/>
+          <a:lstStyle/>
+          <a:p>
+            <a:pPr algn="ctr"/>
+            <a:endParaRPr lang="en-AU"/>
+          </a:p>
+        </p:txBody>
+      </p:sp>
+      <p:sp>
+        <p:nvSpPr>
+          <p:cNvPr id="4" name="Oval 3">
+            <a:extLst>
+              <a:ext uri="{FF2B5EF4-FFF2-40B4-BE49-F238E27FC236}">
+                <a16:creationId xmlns:a16="http://schemas.microsoft.com/office/drawing/2014/main" id="{310A064A-3C87-421E-88DC-A226EE4458E8}"/>
+              </a:ext>
+            </a:extLst>
+          </p:cNvPr>
+          <p:cNvSpPr/>
+          <p:nvPr/>
+        </p:nvSpPr>
+        <p:spPr>
+          <a:xfrm>
+            <a:off x="4968552" y="1935369"/>
+            <a:ext cx="3600" cy="3600"/>
+          </a:xfrm>
+          <a:prstGeom prst="ellipse">
+            <a:avLst/>
+          </a:prstGeom>
+        </p:spPr>
+        <p:style>
+          <a:lnRef idx="2">
+            <a:schemeClr val="accent1">
+              <a:shade val="50000"/>
+            </a:schemeClr>
+          </a:lnRef>
+          <a:fillRef idx="1">
+            <a:schemeClr val="accent1"/>
+          </a:fillRef>
+          <a:effectRef idx="0">
+            <a:schemeClr val="accent1"/>
+          </a:effectRef>
+          <a:fontRef idx="minor">
+            <a:schemeClr val="lt1"/>
+          </a:fontRef>
+        </p:style>
+        <p:txBody>
+          <a:bodyPr rtlCol="0" anchor="ctr"/>
+          <a:lstStyle/>
+          <a:p>
+            <a:pPr algn="ctr"/>
+            <a:endParaRPr lang="en-AU"/>
+          </a:p>
+        </p:txBody>
+      </p:sp>
+      <p:cxnSp>
+        <p:nvCxnSpPr>
+          <p:cNvPr id="6" name="Straight Connector 5">
+            <a:extLst>
+              <a:ext uri="{FF2B5EF4-FFF2-40B4-BE49-F238E27FC236}">
+                <a16:creationId xmlns:a16="http://schemas.microsoft.com/office/drawing/2014/main" id="{5EBEE186-B201-4CF1-90D8-36DAD3404286}"/>
+              </a:ext>
+            </a:extLst>
+          </p:cNvPr>
+          <p:cNvCxnSpPr>
+            <a:cxnSpLocks/>
+            <a:stCxn id="3" idx="2"/>
+            <a:endCxn id="4" idx="3"/>
+          </p:cNvCxnSpPr>
+          <p:nvPr/>
+        </p:nvCxnSpPr>
+        <p:spPr>
+          <a:xfrm flipV="1">
+            <a:off x="2097451" y="1938442"/>
+            <a:ext cx="2871628" cy="2886107"/>
+          </a:xfrm>
+          <a:prstGeom prst="line">
+            <a:avLst/>
+          </a:prstGeom>
+        </p:spPr>
+        <p:style>
+          <a:lnRef idx="1">
+            <a:schemeClr val="accent1"/>
+          </a:lnRef>
+          <a:fillRef idx="0">
+            <a:schemeClr val="accent1"/>
+          </a:fillRef>
+          <a:effectRef idx="0">
+            <a:schemeClr val="accent1"/>
+          </a:effectRef>
+          <a:fontRef idx="minor">
+            <a:schemeClr val="tx1"/>
+          </a:fontRef>
+        </p:style>
+      </p:cxnSp>
+      <p:cxnSp>
+        <p:nvCxnSpPr>
+          <p:cNvPr id="9" name="Straight Connector 8">
+            <a:extLst>
+              <a:ext uri="{FF2B5EF4-FFF2-40B4-BE49-F238E27FC236}">
+                <a16:creationId xmlns:a16="http://schemas.microsoft.com/office/drawing/2014/main" id="{B3597060-8A37-451A-913F-70AC35CFA0C4}"/>
+              </a:ext>
+            </a:extLst>
+          </p:cNvPr>
+          <p:cNvCxnSpPr>
+            <a:cxnSpLocks/>
+            <a:stCxn id="3" idx="6"/>
+            <a:endCxn id="4" idx="6"/>
+          </p:cNvCxnSpPr>
+          <p:nvPr/>
+        </p:nvCxnSpPr>
+        <p:spPr>
+          <a:xfrm flipH="1" flipV="1">
+            <a:off x="4972152" y="1937169"/>
+            <a:ext cx="2885299" cy="2887380"/>
+          </a:xfrm>
+          <a:prstGeom prst="line">
+            <a:avLst/>
+          </a:prstGeom>
+        </p:spPr>
+        <p:style>
+          <a:lnRef idx="1">
+            <a:schemeClr val="accent1"/>
+          </a:lnRef>
+          <a:fillRef idx="0">
+            <a:schemeClr val="accent1"/>
+          </a:fillRef>
+          <a:effectRef idx="0">
+            <a:schemeClr val="accent1"/>
+          </a:effectRef>
+          <a:fontRef idx="minor">
+            <a:schemeClr val="tx1"/>
+          </a:fontRef>
+        </p:style>
+      </p:cxnSp>
+      <p:cxnSp>
+        <p:nvCxnSpPr>
+          <p:cNvPr id="12" name="Straight Connector 11">
+            <a:extLst>
+              <a:ext uri="{FF2B5EF4-FFF2-40B4-BE49-F238E27FC236}">
+                <a16:creationId xmlns:a16="http://schemas.microsoft.com/office/drawing/2014/main" id="{4E37C40E-C39B-4A9E-88C7-90510007C713}"/>
+              </a:ext>
+            </a:extLst>
+          </p:cNvPr>
+          <p:cNvCxnSpPr>
+            <a:cxnSpLocks/>
+            <a:stCxn id="3" idx="3"/>
+            <a:endCxn id="4" idx="4"/>
+          </p:cNvCxnSpPr>
+          <p:nvPr/>
+        </p:nvCxnSpPr>
+        <p:spPr>
+          <a:xfrm flipV="1">
+            <a:off x="2940983" y="1938969"/>
+            <a:ext cx="2029369" cy="3123392"/>
+          </a:xfrm>
+          <a:prstGeom prst="line">
+            <a:avLst/>
+          </a:prstGeom>
+        </p:spPr>
+        <p:style>
+          <a:lnRef idx="1">
+            <a:schemeClr val="accent1"/>
+          </a:lnRef>
+          <a:fillRef idx="0">
+            <a:schemeClr val="accent1"/>
+          </a:fillRef>
+          <a:effectRef idx="0">
+            <a:schemeClr val="accent1"/>
+          </a:effectRef>
+          <a:fontRef idx="minor">
+            <a:schemeClr val="tx1"/>
+          </a:fontRef>
+        </p:style>
+      </p:cxnSp>
+      <p:cxnSp>
+        <p:nvCxnSpPr>
+          <p:cNvPr id="14" name="Straight Connector 13">
+            <a:extLst>
+              <a:ext uri="{FF2B5EF4-FFF2-40B4-BE49-F238E27FC236}">
+                <a16:creationId xmlns:a16="http://schemas.microsoft.com/office/drawing/2014/main" id="{89BBCB57-11A6-4650-BCAF-70CA46423329}"/>
+              </a:ext>
+            </a:extLst>
+          </p:cNvPr>
+          <p:cNvCxnSpPr>
+            <a:cxnSpLocks/>
+            <a:stCxn id="3" idx="1"/>
+            <a:endCxn id="4" idx="3"/>
+          </p:cNvCxnSpPr>
+          <p:nvPr/>
+        </p:nvCxnSpPr>
+        <p:spPr>
+          <a:xfrm flipV="1">
+            <a:off x="2940983" y="1938442"/>
+            <a:ext cx="2028096" cy="2648295"/>
+          </a:xfrm>
+          <a:prstGeom prst="line">
+            <a:avLst/>
+          </a:prstGeom>
+        </p:spPr>
+        <p:style>
+          <a:lnRef idx="1">
+            <a:schemeClr val="accent1"/>
+          </a:lnRef>
+          <a:fillRef idx="0">
+            <a:schemeClr val="accent1"/>
+          </a:fillRef>
+          <a:effectRef idx="0">
+            <a:schemeClr val="accent1"/>
+          </a:effectRef>
+          <a:fontRef idx="minor">
+            <a:schemeClr val="tx1"/>
+          </a:fontRef>
+        </p:style>
+      </p:cxnSp>
+      <p:cxnSp>
+        <p:nvCxnSpPr>
+          <p:cNvPr id="16" name="Straight Connector 15">
+            <a:extLst>
+              <a:ext uri="{FF2B5EF4-FFF2-40B4-BE49-F238E27FC236}">
+                <a16:creationId xmlns:a16="http://schemas.microsoft.com/office/drawing/2014/main" id="{4687E3C6-86B8-44EB-9840-149E7D6DCDC9}"/>
+              </a:ext>
+            </a:extLst>
+          </p:cNvPr>
+          <p:cNvCxnSpPr>
+            <a:cxnSpLocks/>
+            <a:stCxn id="3" idx="7"/>
+            <a:endCxn id="4" idx="2"/>
+          </p:cNvCxnSpPr>
+          <p:nvPr/>
+        </p:nvCxnSpPr>
+        <p:spPr>
+          <a:xfrm flipH="1" flipV="1">
+            <a:off x="4968552" y="1937169"/>
+            <a:ext cx="2045367" cy="2649568"/>
+          </a:xfrm>
+          <a:prstGeom prst="line">
+            <a:avLst/>
+          </a:prstGeom>
+        </p:spPr>
+        <p:style>
+          <a:lnRef idx="1">
+            <a:schemeClr val="accent1"/>
+          </a:lnRef>
+          <a:fillRef idx="0">
+            <a:schemeClr val="accent1"/>
+          </a:fillRef>
+          <a:effectRef idx="0">
+            <a:schemeClr val="accent1"/>
+          </a:effectRef>
+          <a:fontRef idx="minor">
+            <a:schemeClr val="tx1"/>
+          </a:fontRef>
+        </p:style>
+      </p:cxnSp>
+      <p:cxnSp>
+        <p:nvCxnSpPr>
+          <p:cNvPr id="28" name="Straight Connector 27">
+            <a:extLst>
+              <a:ext uri="{FF2B5EF4-FFF2-40B4-BE49-F238E27FC236}">
+                <a16:creationId xmlns:a16="http://schemas.microsoft.com/office/drawing/2014/main" id="{CF768D22-1696-41DA-B3B5-902E5766D5E2}"/>
+              </a:ext>
+            </a:extLst>
+          </p:cNvPr>
+          <p:cNvCxnSpPr>
+            <a:cxnSpLocks/>
+            <a:stCxn id="3" idx="5"/>
+            <a:endCxn id="4" idx="1"/>
+          </p:cNvCxnSpPr>
+          <p:nvPr/>
+        </p:nvCxnSpPr>
+        <p:spPr>
+          <a:xfrm flipH="1" flipV="1">
+            <a:off x="4969079" y="1935896"/>
+            <a:ext cx="2044840" cy="3126465"/>
+          </a:xfrm>
+          <a:prstGeom prst="line">
+            <a:avLst/>
+          </a:prstGeom>
+        </p:spPr>
+        <p:style>
+          <a:lnRef idx="1">
+            <a:schemeClr val="accent1"/>
+          </a:lnRef>
+          <a:fillRef idx="0">
+            <a:schemeClr val="accent1"/>
+          </a:fillRef>
+          <a:effectRef idx="0">
+            <a:schemeClr val="accent1"/>
+          </a:effectRef>
+          <a:fontRef idx="minor">
+            <a:schemeClr val="tx1"/>
+          </a:fontRef>
+        </p:style>
+      </p:cxnSp>
+      <p:cxnSp>
+        <p:nvCxnSpPr>
+          <p:cNvPr id="31" name="Straight Connector 30">
+            <a:extLst>
+              <a:ext uri="{FF2B5EF4-FFF2-40B4-BE49-F238E27FC236}">
+                <a16:creationId xmlns:a16="http://schemas.microsoft.com/office/drawing/2014/main" id="{D1C339E4-7BD3-4ABF-B578-0837360FBBFA}"/>
+              </a:ext>
+            </a:extLst>
+          </p:cNvPr>
+          <p:cNvCxnSpPr>
+            <a:cxnSpLocks/>
+            <a:stCxn id="3" idx="0"/>
+            <a:endCxn id="4" idx="0"/>
+          </p:cNvCxnSpPr>
+          <p:nvPr/>
+        </p:nvCxnSpPr>
+        <p:spPr>
+          <a:xfrm flipH="1" flipV="1">
+            <a:off x="4970352" y="1935369"/>
+            <a:ext cx="7099" cy="2552863"/>
+          </a:xfrm>
+          <a:prstGeom prst="line">
+            <a:avLst/>
+          </a:prstGeom>
+        </p:spPr>
+        <p:style>
+          <a:lnRef idx="1">
+            <a:schemeClr val="accent1"/>
+          </a:lnRef>
+          <a:fillRef idx="0">
+            <a:schemeClr val="accent1"/>
+          </a:fillRef>
+          <a:effectRef idx="0">
+            <a:schemeClr val="accent1"/>
+          </a:effectRef>
+          <a:fontRef idx="minor">
+            <a:schemeClr val="tx1"/>
+          </a:fontRef>
+        </p:style>
+      </p:cxnSp>
+      <p:cxnSp>
+        <p:nvCxnSpPr>
+          <p:cNvPr id="33" name="Straight Connector 32">
+            <a:extLst>
+              <a:ext uri="{FF2B5EF4-FFF2-40B4-BE49-F238E27FC236}">
+                <a16:creationId xmlns:a16="http://schemas.microsoft.com/office/drawing/2014/main" id="{208E3B59-F32F-44F3-BA4C-38CABCBDAC38}"/>
+              </a:ext>
+            </a:extLst>
+          </p:cNvPr>
+          <p:cNvCxnSpPr>
+            <a:cxnSpLocks/>
+            <a:stCxn id="3" idx="4"/>
+            <a:endCxn id="4" idx="3"/>
+          </p:cNvCxnSpPr>
+          <p:nvPr/>
+        </p:nvCxnSpPr>
+        <p:spPr>
+          <a:xfrm flipH="1" flipV="1">
+            <a:off x="4969079" y="1938442"/>
+            <a:ext cx="8372" cy="3222424"/>
+          </a:xfrm>
+          <a:prstGeom prst="line">
+            <a:avLst/>
+          </a:prstGeom>
+        </p:spPr>
+        <p:style>
+          <a:lnRef idx="1">
+            <a:schemeClr val="accent1"/>
+          </a:lnRef>
+          <a:fillRef idx="0">
+            <a:schemeClr val="accent1"/>
+          </a:fillRef>
+          <a:effectRef idx="0">
+            <a:schemeClr val="accent1"/>
+          </a:effectRef>
+          <a:fontRef idx="minor">
+            <a:schemeClr val="tx1"/>
+          </a:fontRef>
+        </p:style>
+      </p:cxnSp>
+      <p:cxnSp>
+        <p:nvCxnSpPr>
+          <p:cNvPr id="35" name="Straight Connector 34">
+            <a:extLst>
+              <a:ext uri="{FF2B5EF4-FFF2-40B4-BE49-F238E27FC236}">
+                <a16:creationId xmlns:a16="http://schemas.microsoft.com/office/drawing/2014/main" id="{DE76313E-CBBA-4EF4-8568-0ABB6D55E4D1}"/>
+              </a:ext>
+            </a:extLst>
+          </p:cNvPr>
+          <p:cNvCxnSpPr>
+            <a:cxnSpLocks/>
+          </p:cNvCxnSpPr>
+          <p:nvPr/>
+        </p:nvCxnSpPr>
+        <p:spPr>
+          <a:xfrm flipH="1" flipV="1">
+            <a:off x="4979990" y="1938969"/>
+            <a:ext cx="1" cy="2885583"/>
+          </a:xfrm>
+          <a:prstGeom prst="line">
+            <a:avLst/>
+          </a:prstGeom>
+          <a:ln w="38100">
+            <a:solidFill>
+              <a:srgbClr val="7030A0"/>
+            </a:solidFill>
+          </a:ln>
+        </p:spPr>
+        <p:style>
+          <a:lnRef idx="1">
+            <a:schemeClr val="accent1"/>
+          </a:lnRef>
+          <a:fillRef idx="0">
+            <a:schemeClr val="accent1"/>
+          </a:fillRef>
+          <a:effectRef idx="0">
+            <a:schemeClr val="accent1"/>
+          </a:effectRef>
+          <a:fontRef idx="minor">
+            <a:schemeClr val="tx1"/>
+          </a:fontRef>
+        </p:style>
+      </p:cxnSp>
+      <p:cxnSp>
+        <p:nvCxnSpPr>
+          <p:cNvPr id="85" name="Straight Connector 84">
+            <a:extLst>
+              <a:ext uri="{FF2B5EF4-FFF2-40B4-BE49-F238E27FC236}">
+                <a16:creationId xmlns:a16="http://schemas.microsoft.com/office/drawing/2014/main" id="{97A99AE4-F662-4B7C-9F2E-3E309EE8E948}"/>
+              </a:ext>
+            </a:extLst>
+          </p:cNvPr>
+          <p:cNvCxnSpPr>
+            <a:cxnSpLocks/>
+            <a:stCxn id="3" idx="2"/>
+            <a:endCxn id="3" idx="6"/>
+          </p:cNvCxnSpPr>
+          <p:nvPr/>
+        </p:nvCxnSpPr>
+        <p:spPr>
+          <a:xfrm>
+            <a:off x="2097451" y="4824549"/>
+            <a:ext cx="5760000" cy="0"/>
+          </a:xfrm>
+          <a:prstGeom prst="line">
+            <a:avLst/>
+          </a:prstGeom>
+        </p:spPr>
+        <p:style>
+          <a:lnRef idx="1">
+            <a:schemeClr val="accent1"/>
+          </a:lnRef>
+          <a:fillRef idx="0">
+            <a:schemeClr val="accent1"/>
+          </a:fillRef>
+          <a:effectRef idx="0">
+            <a:schemeClr val="accent1"/>
+          </a:effectRef>
+          <a:fontRef idx="minor">
+            <a:schemeClr val="tx1"/>
+          </a:fontRef>
+        </p:style>
+      </p:cxnSp>
+      <p:cxnSp>
+        <p:nvCxnSpPr>
+          <p:cNvPr id="91" name="Straight Connector 90">
+            <a:extLst>
+              <a:ext uri="{FF2B5EF4-FFF2-40B4-BE49-F238E27FC236}">
+                <a16:creationId xmlns:a16="http://schemas.microsoft.com/office/drawing/2014/main" id="{FEA0E19F-EE7D-4E58-AF01-6B84C563404E}"/>
+              </a:ext>
+            </a:extLst>
+          </p:cNvPr>
+          <p:cNvCxnSpPr>
+            <a:cxnSpLocks/>
+            <a:stCxn id="3" idx="4"/>
+            <a:endCxn id="3" idx="0"/>
+          </p:cNvCxnSpPr>
+          <p:nvPr/>
+        </p:nvCxnSpPr>
+        <p:spPr>
+          <a:xfrm flipV="1">
+            <a:off x="4977451" y="4488232"/>
+            <a:ext cx="0" cy="672634"/>
+          </a:xfrm>
+          <a:prstGeom prst="line">
+            <a:avLst/>
+          </a:prstGeom>
+        </p:spPr>
+        <p:style>
+          <a:lnRef idx="1">
+            <a:schemeClr val="accent1"/>
+          </a:lnRef>
+          <a:fillRef idx="0">
+            <a:schemeClr val="accent1"/>
+          </a:fillRef>
+          <a:effectRef idx="0">
+            <a:schemeClr val="accent1"/>
+          </a:effectRef>
+          <a:fontRef idx="minor">
+            <a:schemeClr val="tx1"/>
+          </a:fontRef>
+        </p:style>
+      </p:cxnSp>
+      <p:cxnSp>
+        <p:nvCxnSpPr>
+          <p:cNvPr id="18" name="Straight Connector 17">
+            <a:extLst>
+              <a:ext uri="{FF2B5EF4-FFF2-40B4-BE49-F238E27FC236}">
+                <a16:creationId xmlns:a16="http://schemas.microsoft.com/office/drawing/2014/main" id="{C0C44BC3-1777-4E34-A7FD-3B34C9AAFE10}"/>
+              </a:ext>
+            </a:extLst>
+          </p:cNvPr>
+          <p:cNvCxnSpPr>
+            <a:cxnSpLocks/>
+            <a:endCxn id="3" idx="6"/>
+          </p:cNvCxnSpPr>
+          <p:nvPr/>
+        </p:nvCxnSpPr>
+        <p:spPr>
+          <a:xfrm flipV="1">
+            <a:off x="4970879" y="4824549"/>
+            <a:ext cx="2886572" cy="2"/>
+          </a:xfrm>
+          <a:prstGeom prst="line">
+            <a:avLst/>
+          </a:prstGeom>
+          <a:ln w="38100">
+            <a:solidFill>
+              <a:srgbClr val="7030A0"/>
+            </a:solidFill>
+          </a:ln>
+        </p:spPr>
+        <p:style>
+          <a:lnRef idx="1">
+            <a:schemeClr val="accent1"/>
+          </a:lnRef>
+          <a:fillRef idx="0">
+            <a:schemeClr val="accent1"/>
+          </a:fillRef>
+          <a:effectRef idx="0">
+            <a:schemeClr val="accent1"/>
+          </a:effectRef>
+          <a:fontRef idx="minor">
+            <a:schemeClr val="tx1"/>
+          </a:fontRef>
+        </p:style>
+      </p:cxnSp>
+      <p:cxnSp>
+        <p:nvCxnSpPr>
+          <p:cNvPr id="10" name="Straight Connector 9">
+            <a:extLst>
+              <a:ext uri="{FF2B5EF4-FFF2-40B4-BE49-F238E27FC236}">
+                <a16:creationId xmlns:a16="http://schemas.microsoft.com/office/drawing/2014/main" id="{654AA5A2-B422-4CA3-95EC-1139D39D0367}"/>
+              </a:ext>
+            </a:extLst>
+          </p:cNvPr>
+          <p:cNvCxnSpPr>
+            <a:cxnSpLocks/>
+            <a:stCxn id="4" idx="7"/>
+            <a:endCxn id="3" idx="6"/>
+          </p:cNvCxnSpPr>
+          <p:nvPr/>
+        </p:nvCxnSpPr>
+        <p:spPr>
+          <a:xfrm>
+            <a:off x="4971625" y="1935896"/>
+            <a:ext cx="2885826" cy="2888653"/>
+          </a:xfrm>
+          <a:prstGeom prst="line">
+            <a:avLst/>
+          </a:prstGeom>
+          <a:ln w="38100">
+            <a:solidFill>
+              <a:srgbClr val="7030A0"/>
+            </a:solidFill>
+          </a:ln>
+        </p:spPr>
+        <p:style>
+          <a:lnRef idx="1">
+            <a:schemeClr val="accent1"/>
+          </a:lnRef>
+          <a:fillRef idx="0">
+            <a:schemeClr val="accent1"/>
+          </a:fillRef>
+          <a:effectRef idx="0">
+            <a:schemeClr val="accent1"/>
+          </a:effectRef>
+          <a:fontRef idx="minor">
+            <a:schemeClr val="tx1"/>
+          </a:fontRef>
+        </p:style>
+      </p:cxnSp>
+      <mc:AlternateContent xmlns:mc="http://schemas.openxmlformats.org/markup-compatibility/2006">
+        <mc:Choice xmlns:a14="http://schemas.microsoft.com/office/drawing/2010/main" Requires="a14">
+          <p:sp>
+            <p:nvSpPr>
+              <p:cNvPr id="11" name="TextBox 10">
+                <a:extLst>
+                  <a:ext uri="{FF2B5EF4-FFF2-40B4-BE49-F238E27FC236}">
+                    <a16:creationId xmlns:a16="http://schemas.microsoft.com/office/drawing/2014/main" id="{D9A82FB1-09E5-439F-B8BA-66EC0C305100}"/>
+                  </a:ext>
+                </a:extLst>
+              </p:cNvPr>
+              <p:cNvSpPr txBox="1"/>
+              <p:nvPr/>
+            </p:nvSpPr>
+            <p:spPr>
+              <a:xfrm>
+                <a:off x="1407757" y="2512831"/>
+                <a:ext cx="2390775" cy="609077"/>
+              </a:xfrm>
+              <a:prstGeom prst="rect">
+                <a:avLst/>
+              </a:prstGeom>
+              <a:noFill/>
+            </p:spPr>
+            <p:txBody>
+              <a:bodyPr wrap="square" rtlCol="0">
+                <a:spAutoFit/>
+              </a:bodyPr>
+              <a:lstStyle/>
+              <a:p>
+                <a14:m>
+                  <m:oMathPara xmlns:m="http://schemas.openxmlformats.org/officeDocument/2006/math">
+                    <m:oMathParaPr>
+                      <m:jc m:val="centerGroup"/>
+                    </m:oMathParaPr>
+                    <m:oMath xmlns:m="http://schemas.openxmlformats.org/officeDocument/2006/math">
+                      <m:r>
+                        <a:rPr lang="en-GB" b="0" i="1" smtClean="0">
+                          <a:latin typeface="Cambria Math" panose="02040503050406030204" pitchFamily="18" charset="0"/>
+                        </a:rPr>
+                        <m:t>𝑤</m:t>
+                      </m:r>
+                      <m:r>
+                        <a:rPr lang="en-GB" b="0" i="1" smtClean="0">
+                          <a:latin typeface="Cambria Math" panose="02040503050406030204" pitchFamily="18" charset="0"/>
+                        </a:rPr>
+                        <m:t>= </m:t>
+                      </m:r>
+                      <m:f>
+                        <m:fPr>
+                          <m:ctrlPr>
+                            <a:rPr lang="en-GB" b="0" i="1" smtClean="0">
+                              <a:latin typeface="Cambria Math" panose="02040503050406030204" pitchFamily="18" charset="0"/>
+                            </a:rPr>
+                          </m:ctrlPr>
+                        </m:fPr>
+                        <m:num>
+                          <m:sSub>
+                            <m:sSubPr>
+                              <m:ctrlPr>
+                                <a:rPr lang="en-GB" i="1">
+                                  <a:latin typeface="Cambria Math" panose="02040503050406030204" pitchFamily="18" charset="0"/>
+                                </a:rPr>
+                              </m:ctrlPr>
+                            </m:sSubPr>
+                            <m:e>
+                              <m:r>
+                                <a:rPr lang="en-GB" i="1">
+                                  <a:latin typeface="Cambria Math" panose="02040503050406030204" pitchFamily="18" charset="0"/>
+                                </a:rPr>
+                                <m:t>𝑅</m:t>
+                              </m:r>
+                            </m:e>
+                            <m:sub>
+                              <m:r>
+                                <a:rPr lang="en-GB" i="1">
+                                  <a:latin typeface="Cambria Math" panose="02040503050406030204" pitchFamily="18" charset="0"/>
+                                </a:rPr>
+                                <m:t>𝑠</m:t>
+                              </m:r>
+                            </m:sub>
+                          </m:sSub>
+                        </m:num>
+                        <m:den>
+                          <m:r>
+                            <a:rPr lang="en-GB" b="0" i="1" smtClean="0">
+                              <a:latin typeface="Cambria Math" panose="02040503050406030204" pitchFamily="18" charset="0"/>
+                            </a:rPr>
+                            <m:t>𝑟</m:t>
+                          </m:r>
+                        </m:den>
+                      </m:f>
+                    </m:oMath>
+                  </m:oMathPara>
+                </a14:m>
+                <a:endParaRPr lang="en-AU" dirty="0"/>
+              </a:p>
+            </p:txBody>
+          </p:sp>
+        </mc:Choice>
+        <mc:Fallback>
+          <p:sp>
+            <p:nvSpPr>
+              <p:cNvPr id="11" name="TextBox 10">
+                <a:extLst>
+                  <a:ext uri="{FF2B5EF4-FFF2-40B4-BE49-F238E27FC236}">
+                    <a16:creationId xmlns:a16="http://schemas.microsoft.com/office/drawing/2014/main" id="{D9A82FB1-09E5-439F-B8BA-66EC0C305100}"/>
+                  </a:ext>
+                </a:extLst>
+              </p:cNvPr>
+              <p:cNvSpPr txBox="1">
+                <a:spLocks noRot="1" noChangeAspect="1" noMove="1" noResize="1" noEditPoints="1" noAdjustHandles="1" noChangeArrowheads="1" noChangeShapeType="1" noTextEdit="1"/>
+              </p:cNvSpPr>
+              <p:nvPr/>
+            </p:nvSpPr>
+            <p:spPr>
+              <a:xfrm>
+                <a:off x="1407757" y="2512831"/>
+                <a:ext cx="2390775" cy="609077"/>
+              </a:xfrm>
+              <a:prstGeom prst="rect">
+                <a:avLst/>
+              </a:prstGeom>
+              <a:blipFill>
+                <a:blip r:embed="rId2"/>
+                <a:stretch>
+                  <a:fillRect/>
+                </a:stretch>
+              </a:blipFill>
+            </p:spPr>
+            <p:txBody>
+              <a:bodyPr/>
+              <a:lstStyle/>
+              <a:p>
+                <a:r>
+                  <a:rPr lang="en-AU">
+                    <a:noFill/>
+                  </a:rPr>
+                  <a:t> </a:t>
+                </a:r>
+              </a:p>
+            </p:txBody>
+          </p:sp>
+        </mc:Fallback>
+      </mc:AlternateContent>
+      <mc:AlternateContent xmlns:mc="http://schemas.openxmlformats.org/markup-compatibility/2006">
+        <mc:Choice xmlns:a14="http://schemas.microsoft.com/office/drawing/2010/main" Requires="a14">
+          <p:sp>
+            <p:nvSpPr>
+              <p:cNvPr id="13" name="TextBox 12">
+                <a:extLst>
+                  <a:ext uri="{FF2B5EF4-FFF2-40B4-BE49-F238E27FC236}">
+                    <a16:creationId xmlns:a16="http://schemas.microsoft.com/office/drawing/2014/main" id="{11504B03-6766-45CC-ABC9-114AB76F63B3}"/>
+                  </a:ext>
+                </a:extLst>
+              </p:cNvPr>
+              <p:cNvSpPr txBox="1"/>
+              <p:nvPr/>
+            </p:nvSpPr>
+            <p:spPr>
+              <a:xfrm>
+                <a:off x="4519312" y="3195556"/>
+                <a:ext cx="581022" cy="369332"/>
+              </a:xfrm>
+              <a:prstGeom prst="rect">
+                <a:avLst/>
+              </a:prstGeom>
+              <a:noFill/>
+            </p:spPr>
+            <p:txBody>
+              <a:bodyPr wrap="square" rtlCol="0">
+                <a:spAutoFit/>
+              </a:bodyPr>
+              <a:lstStyle/>
+              <a:p>
+                <a14:m>
+                  <m:oMathPara xmlns:m="http://schemas.openxmlformats.org/officeDocument/2006/math">
+                    <m:oMathParaPr>
+                      <m:jc m:val="centerGroup"/>
+                    </m:oMathParaPr>
+                    <m:oMath xmlns:m="http://schemas.openxmlformats.org/officeDocument/2006/math">
+                      <m:r>
+                        <a:rPr lang="en-GB" b="0" i="1" smtClean="0">
+                          <a:solidFill>
+                            <a:srgbClr val="7030A0"/>
+                          </a:solidFill>
+                          <a:latin typeface="Cambria Math" panose="02040503050406030204" pitchFamily="18" charset="0"/>
+                        </a:rPr>
+                        <m:t>𝑄</m:t>
+                      </m:r>
+                    </m:oMath>
+                  </m:oMathPara>
+                </a14:m>
+                <a:endParaRPr lang="en-AU" dirty="0">
+                  <a:solidFill>
+                    <a:srgbClr val="7030A0"/>
+                  </a:solidFill>
+                </a:endParaRPr>
+              </a:p>
+            </p:txBody>
+          </p:sp>
+        </mc:Choice>
+        <mc:Fallback>
+          <p:sp>
+            <p:nvSpPr>
+              <p:cNvPr id="13" name="TextBox 12">
+                <a:extLst>
+                  <a:ext uri="{FF2B5EF4-FFF2-40B4-BE49-F238E27FC236}">
+                    <a16:creationId xmlns:a16="http://schemas.microsoft.com/office/drawing/2014/main" id="{11504B03-6766-45CC-ABC9-114AB76F63B3}"/>
+                  </a:ext>
+                </a:extLst>
+              </p:cNvPr>
+              <p:cNvSpPr txBox="1">
+                <a:spLocks noRot="1" noChangeAspect="1" noMove="1" noResize="1" noEditPoints="1" noAdjustHandles="1" noChangeArrowheads="1" noChangeShapeType="1" noTextEdit="1"/>
+              </p:cNvSpPr>
+              <p:nvPr/>
+            </p:nvSpPr>
+            <p:spPr>
+              <a:xfrm>
+                <a:off x="4519312" y="3195556"/>
+                <a:ext cx="581022" cy="369332"/>
+              </a:xfrm>
+              <a:prstGeom prst="rect">
+                <a:avLst/>
+              </a:prstGeom>
+              <a:blipFill>
+                <a:blip r:embed="rId3"/>
+                <a:stretch>
+                  <a:fillRect b="-9836"/>
+                </a:stretch>
+              </a:blipFill>
+            </p:spPr>
+            <p:txBody>
+              <a:bodyPr/>
+              <a:lstStyle/>
+              <a:p>
+                <a:r>
+                  <a:rPr lang="en-AU">
+                    <a:noFill/>
+                  </a:rPr>
+                  <a:t> </a:t>
+                </a:r>
+              </a:p>
+            </p:txBody>
+          </p:sp>
+        </mc:Fallback>
+      </mc:AlternateContent>
+      <mc:AlternateContent xmlns:mc="http://schemas.openxmlformats.org/markup-compatibility/2006">
+        <mc:Choice xmlns:a14="http://schemas.microsoft.com/office/drawing/2010/main" Requires="a14">
+          <p:sp>
+            <p:nvSpPr>
+              <p:cNvPr id="26" name="TextBox 25">
+                <a:extLst>
+                  <a:ext uri="{FF2B5EF4-FFF2-40B4-BE49-F238E27FC236}">
+                    <a16:creationId xmlns:a16="http://schemas.microsoft.com/office/drawing/2014/main" id="{D6820BC9-20B2-47C0-8AD8-4D78640A7A0B}"/>
+                  </a:ext>
+                </a:extLst>
+              </p:cNvPr>
+              <p:cNvSpPr txBox="1"/>
+              <p:nvPr/>
+            </p:nvSpPr>
+            <p:spPr>
+              <a:xfrm>
+                <a:off x="6103985" y="4800707"/>
+                <a:ext cx="581022" cy="369332"/>
+              </a:xfrm>
+              <a:prstGeom prst="rect">
+                <a:avLst/>
+              </a:prstGeom>
+              <a:noFill/>
+            </p:spPr>
+            <p:txBody>
+              <a:bodyPr wrap="square" rtlCol="0">
+                <a:spAutoFit/>
+              </a:bodyPr>
+              <a:lstStyle/>
+              <a:p>
+                <a14:m>
+                  <m:oMathPara xmlns:m="http://schemas.openxmlformats.org/officeDocument/2006/math">
+                    <m:oMathParaPr>
+                      <m:jc m:val="centerGroup"/>
+                    </m:oMathParaPr>
+                    <m:oMath xmlns:m="http://schemas.openxmlformats.org/officeDocument/2006/math">
+                      <m:r>
+                        <a:rPr lang="en-GB" b="0" i="1" smtClean="0">
+                          <a:solidFill>
+                            <a:srgbClr val="7030A0"/>
+                          </a:solidFill>
+                          <a:latin typeface="Cambria Math" panose="02040503050406030204" pitchFamily="18" charset="0"/>
+                        </a:rPr>
+                        <m:t>𝑊</m:t>
+                      </m:r>
+                    </m:oMath>
+                  </m:oMathPara>
+                </a14:m>
+                <a:endParaRPr lang="en-AU" dirty="0">
+                  <a:solidFill>
+                    <a:srgbClr val="7030A0"/>
+                  </a:solidFill>
+                </a:endParaRPr>
+              </a:p>
+            </p:txBody>
+          </p:sp>
+        </mc:Choice>
+        <mc:Fallback>
+          <p:sp>
+            <p:nvSpPr>
+              <p:cNvPr id="26" name="TextBox 25">
+                <a:extLst>
+                  <a:ext uri="{FF2B5EF4-FFF2-40B4-BE49-F238E27FC236}">
+                    <a16:creationId xmlns:a16="http://schemas.microsoft.com/office/drawing/2014/main" id="{D6820BC9-20B2-47C0-8AD8-4D78640A7A0B}"/>
+                  </a:ext>
+                </a:extLst>
+              </p:cNvPr>
+              <p:cNvSpPr txBox="1">
+                <a:spLocks noRot="1" noChangeAspect="1" noMove="1" noResize="1" noEditPoints="1" noAdjustHandles="1" noChangeArrowheads="1" noChangeShapeType="1" noTextEdit="1"/>
+              </p:cNvSpPr>
+              <p:nvPr/>
+            </p:nvSpPr>
+            <p:spPr>
+              <a:xfrm>
+                <a:off x="6103985" y="4800707"/>
+                <a:ext cx="581022" cy="369332"/>
+              </a:xfrm>
+              <a:prstGeom prst="rect">
+                <a:avLst/>
+              </a:prstGeom>
+              <a:blipFill>
+                <a:blip r:embed="rId4"/>
+                <a:stretch>
+                  <a:fillRect/>
+                </a:stretch>
+              </a:blipFill>
+            </p:spPr>
+            <p:txBody>
+              <a:bodyPr/>
+              <a:lstStyle/>
+              <a:p>
+                <a:r>
+                  <a:rPr lang="en-AU">
+                    <a:noFill/>
+                  </a:rPr>
+                  <a:t> </a:t>
+                </a:r>
+              </a:p>
+            </p:txBody>
+          </p:sp>
+        </mc:Fallback>
+      </mc:AlternateContent>
+      <mc:AlternateContent xmlns:mc="http://schemas.openxmlformats.org/markup-compatibility/2006">
+        <mc:Choice xmlns:a14="http://schemas.microsoft.com/office/drawing/2010/main" Requires="a14">
+          <p:sp>
+            <p:nvSpPr>
+              <p:cNvPr id="17" name="TextBox 16">
+                <a:extLst>
+                  <a:ext uri="{FF2B5EF4-FFF2-40B4-BE49-F238E27FC236}">
+                    <a16:creationId xmlns:a16="http://schemas.microsoft.com/office/drawing/2014/main" id="{16E74B99-02A3-45EE-A6B0-561585471080}"/>
+                  </a:ext>
+                </a:extLst>
+              </p:cNvPr>
+              <p:cNvSpPr txBox="1"/>
+              <p:nvPr/>
+            </p:nvSpPr>
+            <p:spPr>
+              <a:xfrm rot="2660179">
+                <a:off x="6030507" y="3185276"/>
+                <a:ext cx="1203343" cy="369332"/>
+              </a:xfrm>
+              <a:prstGeom prst="rect">
+                <a:avLst/>
+              </a:prstGeom>
+              <a:noFill/>
+            </p:spPr>
+            <p:txBody>
+              <a:bodyPr wrap="none" rtlCol="0">
+                <a:spAutoFit/>
+              </a:bodyPr>
+              <a:lstStyle/>
+              <a:p>
+                <a14:m>
+                  <m:oMathPara xmlns:m="http://schemas.openxmlformats.org/officeDocument/2006/math">
+                    <m:oMathParaPr>
+                      <m:jc m:val="centerGroup"/>
+                    </m:oMathParaPr>
+                    <m:oMath xmlns:m="http://schemas.openxmlformats.org/officeDocument/2006/math">
+                      <m:r>
+                        <a:rPr lang="en-GB" i="1" dirty="0" smtClean="0">
+                          <a:solidFill>
+                            <a:srgbClr val="7030A0"/>
+                          </a:solidFill>
+                          <a:latin typeface="Cambria Math" panose="02040503050406030204" pitchFamily="18" charset="0"/>
+                        </a:rPr>
+                        <m:t>𝑀𝑒𝑟𝑖𝑑𝑖𝑎𝑛</m:t>
+                      </m:r>
+                    </m:oMath>
+                  </m:oMathPara>
+                </a14:m>
+                <a:endParaRPr lang="en-AU" dirty="0">
+                  <a:solidFill>
+                    <a:srgbClr val="7030A0"/>
+                  </a:solidFill>
+                </a:endParaRPr>
+              </a:p>
+            </p:txBody>
+          </p:sp>
+        </mc:Choice>
+        <mc:Fallback>
+          <p:sp>
+            <p:nvSpPr>
+              <p:cNvPr id="17" name="TextBox 16">
+                <a:extLst>
+                  <a:ext uri="{FF2B5EF4-FFF2-40B4-BE49-F238E27FC236}">
+                    <a16:creationId xmlns:a16="http://schemas.microsoft.com/office/drawing/2014/main" id="{16E74B99-02A3-45EE-A6B0-561585471080}"/>
+                  </a:ext>
+                </a:extLst>
+              </p:cNvPr>
+              <p:cNvSpPr txBox="1">
+                <a:spLocks noRot="1" noChangeAspect="1" noMove="1" noResize="1" noEditPoints="1" noAdjustHandles="1" noChangeArrowheads="1" noChangeShapeType="1" noTextEdit="1"/>
+              </p:cNvSpPr>
+              <p:nvPr/>
+            </p:nvSpPr>
+            <p:spPr>
+              <a:xfrm rot="2660179">
+                <a:off x="6030507" y="3185276"/>
+                <a:ext cx="1203343" cy="369332"/>
+              </a:xfrm>
+              <a:prstGeom prst="rect">
+                <a:avLst/>
+              </a:prstGeom>
+              <a:blipFill>
+                <a:blip r:embed="rId5"/>
+                <a:stretch>
+                  <a:fillRect/>
+                </a:stretch>
+              </a:blipFill>
+            </p:spPr>
+            <p:txBody>
+              <a:bodyPr/>
+              <a:lstStyle/>
+              <a:p>
+                <a:r>
+                  <a:rPr lang="en-AU">
+                    <a:noFill/>
+                  </a:rPr>
+                  <a:t> </a:t>
+                </a:r>
+              </a:p>
+            </p:txBody>
+          </p:sp>
+        </mc:Fallback>
+      </mc:AlternateContent>
+      <mc:AlternateContent xmlns:mc="http://schemas.openxmlformats.org/markup-compatibility/2006">
+        <mc:Choice xmlns:a14="http://schemas.microsoft.com/office/drawing/2010/main" Requires="a14">
+          <p:sp>
+            <p:nvSpPr>
+              <p:cNvPr id="19" name="TextBox 18">
+                <a:extLst>
+                  <a:ext uri="{FF2B5EF4-FFF2-40B4-BE49-F238E27FC236}">
+                    <a16:creationId xmlns:a16="http://schemas.microsoft.com/office/drawing/2014/main" id="{ED383D66-12F2-4FDC-B9CA-558B74A4B8BC}"/>
+                  </a:ext>
+                </a:extLst>
+              </p:cNvPr>
+              <p:cNvSpPr txBox="1"/>
+              <p:nvPr/>
+            </p:nvSpPr>
+            <p:spPr>
+              <a:xfrm>
+                <a:off x="4788560" y="4798255"/>
+                <a:ext cx="608060" cy="369332"/>
+              </a:xfrm>
+              <a:prstGeom prst="rect">
+                <a:avLst/>
+              </a:prstGeom>
+              <a:noFill/>
+            </p:spPr>
+            <p:txBody>
+              <a:bodyPr wrap="square" rtlCol="0">
+                <a:spAutoFit/>
+              </a:bodyPr>
+              <a:lstStyle/>
+              <a:p>
+                <a14:m>
+                  <m:oMathPara xmlns:m="http://schemas.openxmlformats.org/officeDocument/2006/math">
+                    <m:oMathParaPr>
+                      <m:jc m:val="centerGroup"/>
+                    </m:oMathParaPr>
+                    <m:oMath xmlns:m="http://schemas.openxmlformats.org/officeDocument/2006/math">
+                      <m:r>
+                        <a:rPr lang="en-GB" i="1" dirty="0" smtClean="0">
+                          <a:latin typeface="Cambria Math" panose="02040503050406030204" pitchFamily="18" charset="0"/>
+                        </a:rPr>
+                        <m:t>0</m:t>
+                      </m:r>
+                    </m:oMath>
+                  </m:oMathPara>
+                </a14:m>
+                <a:endParaRPr lang="en-AU" dirty="0"/>
+              </a:p>
+            </p:txBody>
+          </p:sp>
+        </mc:Choice>
+        <mc:Fallback>
+          <p:sp>
+            <p:nvSpPr>
+              <p:cNvPr id="19" name="TextBox 18">
+                <a:extLst>
+                  <a:ext uri="{FF2B5EF4-FFF2-40B4-BE49-F238E27FC236}">
+                    <a16:creationId xmlns:a16="http://schemas.microsoft.com/office/drawing/2014/main" id="{ED383D66-12F2-4FDC-B9CA-558B74A4B8BC}"/>
+                  </a:ext>
+                </a:extLst>
+              </p:cNvPr>
+              <p:cNvSpPr txBox="1">
+                <a:spLocks noRot="1" noChangeAspect="1" noMove="1" noResize="1" noEditPoints="1" noAdjustHandles="1" noChangeArrowheads="1" noChangeShapeType="1" noTextEdit="1"/>
+              </p:cNvSpPr>
+              <p:nvPr/>
+            </p:nvSpPr>
+            <p:spPr>
+              <a:xfrm>
+                <a:off x="4788560" y="4798255"/>
+                <a:ext cx="608060" cy="369332"/>
+              </a:xfrm>
+              <a:prstGeom prst="rect">
+                <a:avLst/>
+              </a:prstGeom>
+              <a:blipFill>
+                <a:blip r:embed="rId6"/>
+                <a:stretch>
+                  <a:fillRect/>
+                </a:stretch>
+              </a:blipFill>
+            </p:spPr>
+            <p:txBody>
+              <a:bodyPr/>
+              <a:lstStyle/>
+              <a:p>
+                <a:r>
+                  <a:rPr lang="en-AU">
+                    <a:noFill/>
+                  </a:rPr>
+                  <a:t> </a:t>
+                </a:r>
+              </a:p>
+            </p:txBody>
+          </p:sp>
+        </mc:Fallback>
+      </mc:AlternateContent>
+      <mc:AlternateContent xmlns:mc="http://schemas.openxmlformats.org/markup-compatibility/2006">
+        <mc:Choice xmlns:a14="http://schemas.microsoft.com/office/drawing/2010/main" Requires="a14">
+          <p:sp>
+            <p:nvSpPr>
+              <p:cNvPr id="30" name="TextBox 29">
+                <a:extLst>
+                  <a:ext uri="{FF2B5EF4-FFF2-40B4-BE49-F238E27FC236}">
+                    <a16:creationId xmlns:a16="http://schemas.microsoft.com/office/drawing/2014/main" id="{9645CEAB-C4B1-41A5-A9B0-B2FEFFE797C7}"/>
+                  </a:ext>
+                </a:extLst>
+              </p:cNvPr>
+              <p:cNvSpPr txBox="1"/>
+              <p:nvPr/>
+            </p:nvSpPr>
+            <p:spPr>
+              <a:xfrm>
+                <a:off x="4492274" y="1792986"/>
+                <a:ext cx="608060" cy="369332"/>
+              </a:xfrm>
+              <a:prstGeom prst="rect">
+                <a:avLst/>
+              </a:prstGeom>
+              <a:noFill/>
+            </p:spPr>
+            <p:txBody>
+              <a:bodyPr wrap="square" rtlCol="0">
+                <a:spAutoFit/>
+              </a:bodyPr>
+              <a:lstStyle/>
+              <a:p>
+                <a14:m>
+                  <m:oMathPara xmlns:m="http://schemas.openxmlformats.org/officeDocument/2006/math">
+                    <m:oMathParaPr>
+                      <m:jc m:val="centerGroup"/>
+                    </m:oMathParaPr>
+                    <m:oMath xmlns:m="http://schemas.openxmlformats.org/officeDocument/2006/math">
+                      <m:r>
+                        <a:rPr lang="en-GB" i="1" dirty="0" smtClean="0">
+                          <a:latin typeface="Cambria Math" panose="02040503050406030204" pitchFamily="18" charset="0"/>
+                        </a:rPr>
+                        <m:t>0</m:t>
+                      </m:r>
+                    </m:oMath>
+                  </m:oMathPara>
+                </a14:m>
+                <a:endParaRPr lang="en-AU" dirty="0"/>
+              </a:p>
+            </p:txBody>
+          </p:sp>
+        </mc:Choice>
+        <mc:Fallback>
+          <p:sp>
+            <p:nvSpPr>
+              <p:cNvPr id="30" name="TextBox 29">
+                <a:extLst>
+                  <a:ext uri="{FF2B5EF4-FFF2-40B4-BE49-F238E27FC236}">
+                    <a16:creationId xmlns:a16="http://schemas.microsoft.com/office/drawing/2014/main" id="{9645CEAB-C4B1-41A5-A9B0-B2FEFFE797C7}"/>
+                  </a:ext>
+                </a:extLst>
+              </p:cNvPr>
+              <p:cNvSpPr txBox="1">
+                <a:spLocks noRot="1" noChangeAspect="1" noMove="1" noResize="1" noEditPoints="1" noAdjustHandles="1" noChangeArrowheads="1" noChangeShapeType="1" noTextEdit="1"/>
+              </p:cNvSpPr>
+              <p:nvPr/>
+            </p:nvSpPr>
+            <p:spPr>
+              <a:xfrm>
+                <a:off x="4492274" y="1792986"/>
+                <a:ext cx="608060" cy="369332"/>
+              </a:xfrm>
+              <a:prstGeom prst="rect">
+                <a:avLst/>
+              </a:prstGeom>
+              <a:blipFill>
+                <a:blip r:embed="rId7"/>
+                <a:stretch>
+                  <a:fillRect/>
+                </a:stretch>
+              </a:blipFill>
+            </p:spPr>
+            <p:txBody>
+              <a:bodyPr/>
+              <a:lstStyle/>
+              <a:p>
+                <a:r>
+                  <a:rPr lang="en-AU">
+                    <a:noFill/>
+                  </a:rPr>
+                  <a:t> </a:t>
+                </a:r>
+              </a:p>
+            </p:txBody>
+          </p:sp>
+        </mc:Fallback>
+      </mc:AlternateContent>
+      <mc:AlternateContent xmlns:mc="http://schemas.openxmlformats.org/markup-compatibility/2006">
+        <mc:Choice xmlns:a14="http://schemas.microsoft.com/office/drawing/2010/main" Requires="a14">
+          <p:sp>
+            <p:nvSpPr>
+              <p:cNvPr id="32" name="TextBox 31">
+                <a:extLst>
+                  <a:ext uri="{FF2B5EF4-FFF2-40B4-BE49-F238E27FC236}">
+                    <a16:creationId xmlns:a16="http://schemas.microsoft.com/office/drawing/2014/main" id="{30266551-3312-44D2-BB9E-3D8B15D1581F}"/>
+                  </a:ext>
+                </a:extLst>
+              </p:cNvPr>
+              <p:cNvSpPr txBox="1"/>
+              <p:nvPr/>
+            </p:nvSpPr>
+            <p:spPr>
+              <a:xfrm>
+                <a:off x="4525475" y="4479779"/>
+                <a:ext cx="608060" cy="369332"/>
+              </a:xfrm>
+              <a:prstGeom prst="rect">
+                <a:avLst/>
+              </a:prstGeom>
+              <a:noFill/>
+            </p:spPr>
+            <p:txBody>
+              <a:bodyPr wrap="square" rtlCol="0">
+                <a:spAutoFit/>
+              </a:bodyPr>
+              <a:lstStyle/>
+              <a:p>
+                <a14:m>
+                  <m:oMathPara xmlns:m="http://schemas.openxmlformats.org/officeDocument/2006/math">
+                    <m:oMathParaPr>
+                      <m:jc m:val="centerGroup"/>
+                    </m:oMathParaPr>
+                    <m:oMath xmlns:m="http://schemas.openxmlformats.org/officeDocument/2006/math">
+                      <m:r>
+                        <a:rPr lang="en-GB" b="0" i="1" dirty="0" smtClean="0">
+                          <a:latin typeface="Cambria Math" panose="02040503050406030204" pitchFamily="18" charset="0"/>
+                        </a:rPr>
+                        <m:t>1</m:t>
+                      </m:r>
+                    </m:oMath>
+                  </m:oMathPara>
+                </a14:m>
+                <a:endParaRPr lang="en-AU" dirty="0"/>
+              </a:p>
+            </p:txBody>
+          </p:sp>
+        </mc:Choice>
+        <mc:Fallback>
+          <p:sp>
+            <p:nvSpPr>
+              <p:cNvPr id="32" name="TextBox 31">
+                <a:extLst>
+                  <a:ext uri="{FF2B5EF4-FFF2-40B4-BE49-F238E27FC236}">
+                    <a16:creationId xmlns:a16="http://schemas.microsoft.com/office/drawing/2014/main" id="{30266551-3312-44D2-BB9E-3D8B15D1581F}"/>
+                  </a:ext>
+                </a:extLst>
+              </p:cNvPr>
+              <p:cNvSpPr txBox="1">
+                <a:spLocks noRot="1" noChangeAspect="1" noMove="1" noResize="1" noEditPoints="1" noAdjustHandles="1" noChangeArrowheads="1" noChangeShapeType="1" noTextEdit="1"/>
+              </p:cNvSpPr>
+              <p:nvPr/>
+            </p:nvSpPr>
+            <p:spPr>
+              <a:xfrm>
+                <a:off x="4525475" y="4479779"/>
+                <a:ext cx="608060" cy="369332"/>
+              </a:xfrm>
+              <a:prstGeom prst="rect">
+                <a:avLst/>
+              </a:prstGeom>
+              <a:blipFill>
+                <a:blip r:embed="rId8"/>
+                <a:stretch>
+                  <a:fillRect/>
+                </a:stretch>
+              </a:blipFill>
+            </p:spPr>
+            <p:txBody>
+              <a:bodyPr/>
+              <a:lstStyle/>
+              <a:p>
+                <a:r>
+                  <a:rPr lang="en-AU">
+                    <a:noFill/>
+                  </a:rPr>
+                  <a:t> </a:t>
+                </a:r>
+              </a:p>
+            </p:txBody>
+          </p:sp>
+        </mc:Fallback>
+      </mc:AlternateContent>
+      <mc:AlternateContent xmlns:mc="http://schemas.openxmlformats.org/markup-compatibility/2006">
+        <mc:Choice xmlns:a14="http://schemas.microsoft.com/office/drawing/2010/main" Requires="a14">
+          <p:sp>
+            <p:nvSpPr>
+              <p:cNvPr id="44" name="TextBox 43">
+                <a:extLst>
+                  <a:ext uri="{FF2B5EF4-FFF2-40B4-BE49-F238E27FC236}">
+                    <a16:creationId xmlns:a16="http://schemas.microsoft.com/office/drawing/2014/main" id="{AA924D25-4C40-457A-A34E-8FCE8B45A6A1}"/>
+                  </a:ext>
+                </a:extLst>
+              </p:cNvPr>
+              <p:cNvSpPr txBox="1"/>
+              <p:nvPr/>
+            </p:nvSpPr>
+            <p:spPr>
+              <a:xfrm>
+                <a:off x="7550227" y="4803798"/>
+                <a:ext cx="608060" cy="369332"/>
+              </a:xfrm>
+              <a:prstGeom prst="rect">
+                <a:avLst/>
+              </a:prstGeom>
+              <a:noFill/>
+            </p:spPr>
+            <p:txBody>
+              <a:bodyPr wrap="square" rtlCol="0">
+                <a:spAutoFit/>
+              </a:bodyPr>
+              <a:lstStyle/>
+              <a:p>
+                <a14:m>
+                  <m:oMathPara xmlns:m="http://schemas.openxmlformats.org/officeDocument/2006/math">
+                    <m:oMathParaPr>
+                      <m:jc m:val="centerGroup"/>
+                    </m:oMathParaPr>
+                    <m:oMath xmlns:m="http://schemas.openxmlformats.org/officeDocument/2006/math">
+                      <m:r>
+                        <a:rPr lang="en-GB" b="0" i="1" dirty="0" smtClean="0">
+                          <a:latin typeface="Cambria Math" panose="02040503050406030204" pitchFamily="18" charset="0"/>
+                        </a:rPr>
+                        <m:t>1</m:t>
+                      </m:r>
+                    </m:oMath>
+                  </m:oMathPara>
+                </a14:m>
+                <a:endParaRPr lang="en-AU" dirty="0"/>
+              </a:p>
+            </p:txBody>
+          </p:sp>
+        </mc:Choice>
+        <mc:Fallback>
+          <p:sp>
+            <p:nvSpPr>
+              <p:cNvPr id="44" name="TextBox 43">
+                <a:extLst>
+                  <a:ext uri="{FF2B5EF4-FFF2-40B4-BE49-F238E27FC236}">
+                    <a16:creationId xmlns:a16="http://schemas.microsoft.com/office/drawing/2014/main" id="{AA924D25-4C40-457A-A34E-8FCE8B45A6A1}"/>
+                  </a:ext>
+                </a:extLst>
+              </p:cNvPr>
+              <p:cNvSpPr txBox="1">
+                <a:spLocks noRot="1" noChangeAspect="1" noMove="1" noResize="1" noEditPoints="1" noAdjustHandles="1" noChangeArrowheads="1" noChangeShapeType="1" noTextEdit="1"/>
+              </p:cNvSpPr>
+              <p:nvPr/>
+            </p:nvSpPr>
+            <p:spPr>
+              <a:xfrm>
+                <a:off x="7550227" y="4803798"/>
+                <a:ext cx="608060" cy="369332"/>
+              </a:xfrm>
+              <a:prstGeom prst="rect">
+                <a:avLst/>
+              </a:prstGeom>
+              <a:blipFill>
+                <a:blip r:embed="rId9"/>
+                <a:stretch>
+                  <a:fillRect/>
+                </a:stretch>
+              </a:blipFill>
+            </p:spPr>
+            <p:txBody>
+              <a:bodyPr/>
+              <a:lstStyle/>
+              <a:p>
+                <a:r>
+                  <a:rPr lang="en-AU">
+                    <a:noFill/>
+                  </a:rPr>
+                  <a:t> </a:t>
+                </a:r>
+              </a:p>
+            </p:txBody>
+          </p:sp>
+        </mc:Fallback>
+      </mc:AlternateContent>
+      <p:sp>
+        <p:nvSpPr>
+          <p:cNvPr id="40" name="TextBox 39">
+            <a:extLst>
+              <a:ext uri="{FF2B5EF4-FFF2-40B4-BE49-F238E27FC236}">
+                <a16:creationId xmlns:a16="http://schemas.microsoft.com/office/drawing/2014/main" id="{2379F8C0-A605-4EB6-91EF-9E361A5704BC}"/>
+              </a:ext>
+            </a:extLst>
+          </p:cNvPr>
+          <p:cNvSpPr txBox="1"/>
+          <p:nvPr/>
+        </p:nvSpPr>
+        <p:spPr>
+          <a:xfrm>
+            <a:off x="4895852" y="5127507"/>
+            <a:ext cx="1924050" cy="369332"/>
+          </a:xfrm>
+          <a:prstGeom prst="rect">
+            <a:avLst/>
+          </a:prstGeom>
+          <a:noFill/>
+        </p:spPr>
+        <p:txBody>
+          <a:bodyPr wrap="square" rtlCol="0">
+            <a:spAutoFit/>
+          </a:bodyPr>
+          <a:lstStyle/>
+          <a:p>
+            <a:r>
+              <a:rPr lang="en-GB" dirty="0"/>
+              <a:t>Event Horizon</a:t>
+            </a:r>
+            <a:endParaRPr lang="en-AU" dirty="0"/>
+          </a:p>
+        </p:txBody>
+      </p:sp>
+      <p:sp>
+        <p:nvSpPr>
+          <p:cNvPr id="41" name="TextBox 40">
+            <a:extLst>
+              <a:ext uri="{FF2B5EF4-FFF2-40B4-BE49-F238E27FC236}">
+                <a16:creationId xmlns:a16="http://schemas.microsoft.com/office/drawing/2014/main" id="{B8F5E3A8-706C-4FB0-8B0B-CABD9FD70BAE}"/>
+              </a:ext>
+            </a:extLst>
+          </p:cNvPr>
+          <p:cNvSpPr txBox="1"/>
+          <p:nvPr/>
+        </p:nvSpPr>
+        <p:spPr>
+          <a:xfrm>
+            <a:off x="5057998" y="1792985"/>
+            <a:ext cx="1431645" cy="369332"/>
+          </a:xfrm>
+          <a:prstGeom prst="rect">
+            <a:avLst/>
+          </a:prstGeom>
+          <a:noFill/>
+        </p:spPr>
+        <p:txBody>
+          <a:bodyPr wrap="square" rtlCol="0">
+            <a:spAutoFit/>
+          </a:bodyPr>
+          <a:lstStyle/>
+          <a:p>
+            <a:r>
+              <a:rPr lang="en-GB" dirty="0"/>
+              <a:t>Free Space</a:t>
+            </a:r>
+            <a:endParaRPr lang="en-AU" dirty="0"/>
+          </a:p>
+        </p:txBody>
+      </p:sp>
+      <p:sp>
+        <p:nvSpPr>
+          <p:cNvPr id="45" name="Arc 44" hidden="1">
+            <a:extLst>
+              <a:ext uri="{FF2B5EF4-FFF2-40B4-BE49-F238E27FC236}">
+                <a16:creationId xmlns:a16="http://schemas.microsoft.com/office/drawing/2014/main" id="{012F6913-1623-4C49-84F3-749C70B2C3EA}"/>
+              </a:ext>
+            </a:extLst>
+          </p:cNvPr>
+          <p:cNvSpPr/>
+          <p:nvPr/>
+        </p:nvSpPr>
+        <p:spPr>
+          <a:xfrm>
+            <a:off x="2124038" y="1935369"/>
+            <a:ext cx="5734050" cy="6000750"/>
+          </a:xfrm>
+          <a:prstGeom prst="arc">
+            <a:avLst/>
+          </a:prstGeom>
+          <a:ln>
+            <a:prstDash val="dash"/>
+          </a:ln>
+        </p:spPr>
+        <p:style>
+          <a:lnRef idx="1">
+            <a:schemeClr val="accent1"/>
+          </a:lnRef>
+          <a:fillRef idx="0">
+            <a:schemeClr val="accent1"/>
+          </a:fillRef>
+          <a:effectRef idx="0">
+            <a:schemeClr val="accent1"/>
+          </a:effectRef>
+          <a:fontRef idx="minor">
+            <a:schemeClr val="tx1"/>
+          </a:fontRef>
+        </p:style>
+        <p:txBody>
+          <a:bodyPr rtlCol="0" anchor="ctr"/>
+          <a:lstStyle/>
+          <a:p>
+            <a:pPr algn="ctr"/>
+            <a:endParaRPr lang="en-AU"/>
+          </a:p>
+        </p:txBody>
+      </p:sp>
+      <p:sp>
+        <p:nvSpPr>
+          <p:cNvPr id="46" name="TextBox 45" hidden="1">
+            <a:extLst>
+              <a:ext uri="{FF2B5EF4-FFF2-40B4-BE49-F238E27FC236}">
+                <a16:creationId xmlns:a16="http://schemas.microsoft.com/office/drawing/2014/main" id="{10BE44B3-FA9F-4FEC-873A-E1A90DB85E9E}"/>
+              </a:ext>
+            </a:extLst>
+          </p:cNvPr>
+          <p:cNvSpPr txBox="1"/>
+          <p:nvPr/>
+        </p:nvSpPr>
+        <p:spPr>
+          <a:xfrm rot="3700048">
+            <a:off x="6764489" y="3223332"/>
+            <a:ext cx="1596643" cy="276999"/>
+          </a:xfrm>
+          <a:prstGeom prst="rect">
+            <a:avLst/>
+          </a:prstGeom>
+          <a:noFill/>
+        </p:spPr>
+        <p:txBody>
+          <a:bodyPr wrap="square" rtlCol="0">
+            <a:spAutoFit/>
+          </a:bodyPr>
+          <a:lstStyle/>
+          <a:p>
+            <a:r>
+              <a:rPr lang="en-GB" sz="1200" dirty="0">
+                <a:solidFill>
+                  <a:schemeClr val="accent5">
+                    <a:lumMod val="75000"/>
+                  </a:schemeClr>
+                </a:solidFill>
+              </a:rPr>
+              <a:t>Hypersphere Meridian</a:t>
+            </a:r>
+            <a:endParaRPr lang="en-AU" sz="1200" dirty="0">
+              <a:solidFill>
+                <a:schemeClr val="accent5">
+                  <a:lumMod val="75000"/>
+                </a:schemeClr>
+              </a:solidFill>
+            </a:endParaRPr>
+          </a:p>
+        </p:txBody>
+      </p:sp>
+    </p:spTree>
+    <p:extLst>
+      <p:ext uri="{BB962C8B-B14F-4D97-AF65-F5344CB8AC3E}">
+        <p14:creationId xmlns:p14="http://schemas.microsoft.com/office/powerpoint/2010/main" val="323729289"/>
+      </p:ext>
+    </p:extLst>
+  </p:cSld>
+  <p:clrMapOvr>
+    <a:masterClrMapping/>
+  </p:clrMapOvr>
+</p:sld>
+</file>
+
 <file path=ppt/theme/theme1.xml><?xml version="1.0" encoding="utf-8"?>
 <a:theme xmlns:a="http://schemas.openxmlformats.org/drawingml/2006/main" name="Office Theme">
   <a:themeElements>

</xml_diff>